<commit_message>
Fix European-Portuguese spellings in the seminar deck (PT-PT vs PT-BR)
"Objectivos", "Arquitectura", "directo", "actua" and "trajectória(s)" are
European Portuguese spelling — the dissertation itself and every other part
of this Brazilian (UFPE) presentation use the Brazilian forms without the
silent consonant. Fixed all 10 occurrences across the Agenda, Motivação,
Objetivos, Arquitetura, Papéis and Metodologia slides. Re-validated
(schema/relationships passed) and re-read the content to confirm zero
matches remain for any of the affected words.
</commit_message>
<xml_diff>
--- a/disserta-apresenta/apresentacao_seminario.pptx
+++ b/disserta-apresenta/apresentacao_seminario.pptx
@@ -6434,7 +6434,7 @@
                 </a:solidFill>
                 <a:latin typeface="Calibri"/>
               </a:rPr>
-              <a:t>✓  Sem acesso directo ao ROS 2</a:t>
+              <a:t>✓  Sem acesso direto ao ROS 2</a:t>
             </a:r>
           </a:p>
         </p:txBody>
@@ -6800,7 +6800,7 @@
                 </a:solidFill>
                 <a:latin typeface="Calibri"/>
               </a:rPr>
-              <a:t>Cada agente só actua no seu próprio robô — um agente nunca move o robô de outro.</a:t>
+              <a:t>Cada agente só atua no seu próprio robô — um agente nunca move o robô de outro.</a:t>
             </a:r>
           </a:p>
         </p:txBody>
@@ -8310,7 +8310,7 @@
                 </a:solidFill>
                 <a:latin typeface="Calibri"/>
               </a:rPr>
-              <a:t>02.  Objectivos</a:t>
+              <a:t>02.  Objetivos</a:t>
             </a:r>
           </a:p>
         </p:txBody>
@@ -8388,7 +8388,7 @@
                 </a:solidFill>
                 <a:latin typeface="Calibri"/>
               </a:rPr>
-              <a:t>03.  Arquitectura do sistema + Agentes de IA</a:t>
+              <a:t>03.  Arquitetura do sistema + Agentes de IA</a:t>
             </a:r>
           </a:p>
         </p:txBody>
@@ -9275,7 +9275,7 @@
                 </a:solidFill>
                 <a:latin typeface="Calibri"/>
               </a:rPr>
-              <a:t>    • Arquitectura de papéis para testbeds distribuídos (MUUT / FUUT / SU)</a:t>
+              <a:t>    • Arquitetura de papéis para testbeds distribuídos (MUUT / FUUT / SU)</a:t>
             </a:r>
           </a:p>
         </p:txBody>
@@ -9457,7 +9457,7 @@
                 </a:solidFill>
                 <a:latin typeface="Calibri"/>
               </a:rPr>
-              <a:t>Objectivos</a:t>
+              <a:t>Objetivos</a:t>
             </a:r>
           </a:p>
         </p:txBody>
@@ -10395,7 +10395,7 @@
                 </a:solidFill>
                 <a:latin typeface="Calibri"/>
               </a:rPr>
-              <a:t>Arquitectura do Sistema</a:t>
+              <a:t>Arquitetura do Sistema</a:t>
             </a:r>
           </a:p>
         </p:txBody>
@@ -11325,7 +11325,7 @@
                 </a:solidFill>
                 <a:latin typeface="Calibri"/>
               </a:rPr>
-              <a:t>Arquitectura de responsabilidades por unidade robótica</a:t>
+              <a:t>Arquitetura de responsabilidades por unidade robótica</a:t>
             </a:r>
           </a:p>
         </p:txBody>
@@ -11734,7 +11734,7 @@
                 </a:solidFill>
                 <a:latin typeface="Calibri"/>
               </a:rPr>
-              <a:t>✓  Fonte de trajectória repetível</a:t>
+              <a:t>✓  Fonte de trajetória repetível</a:t>
             </a:r>
           </a:p>
         </p:txBody>
@@ -13815,7 +13815,7 @@
                 </a:solidFill>
                 <a:latin typeface="Calibri"/>
               </a:rPr>
-              <a:t>⚠  Entre repetições: go_to_point(0,0,0) para retornar ao ponto de partida — condição necessária para a comparação de trajectórias.</a:t>
+              <a:t>⚠  Entre repetições: go_to_point(0,0,0) para retornar ao ponto de partida — condição necessária para a comparação de trajetórias.</a:t>
             </a:r>
           </a:p>
         </p:txBody>

</xml_diff>

<commit_message>
Atualiza apresentacao_seminario.pptx com o novo Slide 11 (Fonte de Trajetória) e Trabalho Futuro
Insere slide novo entre "Distribuição do RMSE" e "Desafios Técnicos" com
o gráfico real fonte_trajetoria_rmse.png + 2 cartões de destaque (maior
diferença na rota Loop ~12cm, diferença desprezível na rota Curta <4cm),
acompanhando o conteúdo já adicionado a fala_apresentacao.txt. Atualiza
também o slide de Trabalho Futuro: remove o item "N maior" (superado
pela campanha real já executada) e adiciona avaliação de impacto da
camada de agentes de IA na repetibilidade.

Co-Authored-By: Claude Sonnet 5 <noreply@anthropic.com>
</commit_message>
<xml_diff>
--- a/disserta-apresenta/apresentacao_seminario.pptx
+++ b/disserta-apresenta/apresentacao_seminario.pptx
@@ -15,6 +15,7 @@
     <p:sldId id="262" r:id="rId9"/>
     <p:sldId id="263" r:id="rId10"/>
     <p:sldId id="264" r:id="rId11"/>
+    <p:sldId id="269" r:id="rId19"/>
     <p:sldId id="265" r:id="rId12"/>
     <p:sldId id="268" r:id="rId13"/>
     <p:sldId id="266" r:id="rId14"/>
@@ -6587,7 +6588,7 @@
                 </a:solidFill>
                 <a:latin typeface="Calibri"/>
               </a:rPr>
-              <a:t>Campanha com N maior (10–20 réplicas) para significância estatística</a:t>
+              <a:t>Avaliar se a camada de agentes de IA degrada a repetibilidade</a:t>
             </a:r>
           </a:p>
         </p:txBody>
@@ -7078,7 +7079,7 @@
                 </a:solidFill>
                 <a:latin typeface="Calibri"/>
               </a:rPr>
-              <a:t>→  Próximo: metodologia baseline/replay + campanha estatística maior</a:t>
+              <a:t>→  Próximo: baseline via play_route + avaliar impacto dos agentes de IA</a:t>
             </a:r>
           </a:p>
         </p:txBody>
@@ -7114,6 +7115,950 @@
                 <a:latin typeface="Calibri"/>
               </a:rPr>
               <a:t>Obrigado — Questões?</a:t>
+            </a:r>
+          </a:p>
+        </p:txBody>
+      </p:sp>
+    </p:spTree>
+  </p:cSld>
+  <p:clrMapOvr>
+    <a:masterClrMapping/>
+  </p:clrMapOvr>
+</p:sld>
+</file>
+
+<file path=ppt/slides/slide14.xml><?xml version="1.0" encoding="utf-8"?>
+<p:sld xmlns:a="http://schemas.openxmlformats.org/drawingml/2006/main" xmlns:r="http://schemas.openxmlformats.org/officeDocument/2006/relationships" xmlns:p="http://schemas.openxmlformats.org/presentationml/2006/main">
+  <p:cSld>
+    <p:spTree>
+      <p:nvGrpSpPr>
+        <p:cNvPr id="1" name=""/>
+        <p:cNvGrpSpPr/>
+        <p:nvPr/>
+      </p:nvGrpSpPr>
+      <p:grpSpPr>
+        <a:xfrm>
+          <a:off x="0" y="0"/>
+          <a:ext cx="0" cy="0"/>
+          <a:chOff x="0" y="0"/>
+          <a:chExt cx="0" cy="0"/>
+        </a:xfrm>
+      </p:grpSpPr>
+      <p:sp>
+        <p:nvSpPr>
+          <p:cNvPr id="2" name="Rectangle 1"/>
+          <p:cNvSpPr/>
+          <p:nvPr/>
+        </p:nvSpPr>
+        <p:spPr>
+          <a:xfrm>
+            <a:off x="0" y="0"/>
+            <a:ext cx="12188952" cy="6858000"/>
+          </a:xfrm>
+          <a:prstGeom prst="rect">
+            <a:avLst/>
+          </a:prstGeom>
+          <a:solidFill>
+            <a:srgbClr val="FFFFFF"/>
+          </a:solidFill>
+          <a:ln>
+            <a:noFill/>
+          </a:ln>
+        </p:spPr>
+        <p:style>
+          <a:lnRef idx="1">
+            <a:schemeClr val="accent1"/>
+          </a:lnRef>
+          <a:fillRef idx="3">
+            <a:schemeClr val="accent1"/>
+          </a:fillRef>
+          <a:effectRef idx="2">
+            <a:schemeClr val="accent1"/>
+          </a:effectRef>
+          <a:fontRef idx="minor">
+            <a:schemeClr val="lt1"/>
+          </a:fontRef>
+        </p:style>
+        <p:txBody>
+          <a:bodyPr rtlCol="0" anchor="ctr"/>
+          <a:lstStyle/>
+          <a:p>
+            <a:pPr algn="ctr"/>
+            <a:endParaRPr/>
+          </a:p>
+        </p:txBody>
+      </p:sp>
+      <p:sp>
+        <p:nvSpPr>
+          <p:cNvPr id="3" name="Rectangle 2"/>
+          <p:cNvSpPr/>
+          <p:nvPr/>
+        </p:nvSpPr>
+        <p:spPr>
+          <a:xfrm>
+            <a:off x="0" y="0"/>
+            <a:ext cx="12188952" cy="1143000"/>
+          </a:xfrm>
+          <a:prstGeom prst="rect">
+            <a:avLst/>
+          </a:prstGeom>
+          <a:solidFill>
+            <a:srgbClr val="1B2A4A"/>
+          </a:solidFill>
+          <a:ln>
+            <a:noFill/>
+          </a:ln>
+        </p:spPr>
+        <p:style>
+          <a:lnRef idx="1">
+            <a:schemeClr val="accent1"/>
+          </a:lnRef>
+          <a:fillRef idx="3">
+            <a:schemeClr val="accent1"/>
+          </a:fillRef>
+          <a:effectRef idx="2">
+            <a:schemeClr val="accent1"/>
+          </a:effectRef>
+          <a:fontRef idx="minor">
+            <a:schemeClr val="lt1"/>
+          </a:fontRef>
+        </p:style>
+        <p:txBody>
+          <a:bodyPr rtlCol="0" anchor="ctr"/>
+          <a:lstStyle/>
+          <a:p>
+            <a:pPr algn="ctr"/>
+            <a:endParaRPr/>
+          </a:p>
+        </p:txBody>
+      </p:sp>
+      <p:sp>
+        <p:nvSpPr>
+          <p:cNvPr id="4" name="Rectangle 3"/>
+          <p:cNvSpPr/>
+          <p:nvPr/>
+        </p:nvSpPr>
+        <p:spPr>
+          <a:xfrm>
+            <a:off x="0" y="1143000"/>
+            <a:ext cx="12188952" cy="45720"/>
+          </a:xfrm>
+          <a:prstGeom prst="rect">
+            <a:avLst/>
+          </a:prstGeom>
+          <a:solidFill>
+            <a:srgbClr val="225AC2"/>
+          </a:solidFill>
+          <a:ln>
+            <a:noFill/>
+          </a:ln>
+        </p:spPr>
+        <p:style>
+          <a:lnRef idx="1">
+            <a:schemeClr val="accent1"/>
+          </a:lnRef>
+          <a:fillRef idx="3">
+            <a:schemeClr val="accent1"/>
+          </a:fillRef>
+          <a:effectRef idx="2">
+            <a:schemeClr val="accent1"/>
+          </a:effectRef>
+          <a:fontRef idx="minor">
+            <a:schemeClr val="lt1"/>
+          </a:fontRef>
+        </p:style>
+        <p:txBody>
+          <a:bodyPr rtlCol="0" anchor="ctr"/>
+          <a:lstStyle/>
+          <a:p>
+            <a:pPr algn="ctr"/>
+            <a:endParaRPr/>
+          </a:p>
+        </p:txBody>
+      </p:sp>
+      <p:sp>
+        <p:nvSpPr>
+          <p:cNvPr id="5" name="TextBox 4"/>
+          <p:cNvSpPr txBox="1"/>
+          <p:nvPr/>
+        </p:nvSpPr>
+        <p:spPr>
+          <a:xfrm>
+            <a:off x="457200" y="137160"/>
+            <a:ext cx="11430000" cy="640080"/>
+          </a:xfrm>
+          <a:prstGeom prst="rect">
+            <a:avLst/>
+          </a:prstGeom>
+          <a:noFill/>
+        </p:spPr>
+        <p:txBody>
+          <a:bodyPr wrap="square">
+            <a:spAutoFit/>
+          </a:bodyPr>
+          <a:lstStyle/>
+          <a:p>
+            <a:pPr algn="l"/>
+            <a:r>
+              <a:rPr sz="3000" b="1" i="0">
+                <a:solidFill>
+                  <a:srgbClr val="FFFFFF"/>
+                </a:solidFill>
+                <a:latin typeface="Calibri"/>
+              </a:rPr>
+              <a:t>Fonte de Trajetória: Odometria, SLAM e Ground Truth</a:t>
+            </a:r>
+          </a:p>
+        </p:txBody>
+      </p:sp>
+      <p:sp>
+        <p:nvSpPr>
+          <p:cNvPr id="6" name="TextBox 5"/>
+          <p:cNvSpPr txBox="1"/>
+          <p:nvPr/>
+        </p:nvSpPr>
+        <p:spPr>
+          <a:xfrm>
+            <a:off x="457200" y="749808"/>
+            <a:ext cx="11430000" cy="347472"/>
+          </a:xfrm>
+          <a:prstGeom prst="rect">
+            <a:avLst/>
+          </a:prstGeom>
+          <a:noFill/>
+        </p:spPr>
+        <p:txBody>
+          <a:bodyPr wrap="square">
+            <a:spAutoFit/>
+          </a:bodyPr>
+          <a:lstStyle/>
+          <a:p>
+            <a:pPr algn="l"/>
+            <a:r>
+              <a:rPr sz="1400" b="0" i="0">
+                <a:solidFill>
+                  <a:srgbClr val="BFDBFF"/>
+                </a:solidFill>
+                <a:latin typeface="Calibri"/>
+              </a:rPr>
+              <a:t>odom vs. pose (SLAM) vs. ground truth nativo do Gazebo  ·  3 rotas, 10 réplicas cada</a:t>
+            </a:r>
+          </a:p>
+        </p:txBody>
+      </p:sp>
+      <p:sp>
+        <p:nvSpPr>
+          <p:cNvPr id="7" name="Rectangle 6"/>
+          <p:cNvSpPr/>
+          <p:nvPr/>
+        </p:nvSpPr>
+        <p:spPr>
+          <a:xfrm>
+            <a:off x="0" y="6537960"/>
+            <a:ext cx="12188952" cy="320040"/>
+          </a:xfrm>
+          <a:prstGeom prst="rect">
+            <a:avLst/>
+          </a:prstGeom>
+          <a:solidFill>
+            <a:srgbClr val="1B2A4A"/>
+          </a:solidFill>
+          <a:ln>
+            <a:noFill/>
+          </a:ln>
+        </p:spPr>
+        <p:style>
+          <a:lnRef idx="1">
+            <a:schemeClr val="accent1"/>
+          </a:lnRef>
+          <a:fillRef idx="3">
+            <a:schemeClr val="accent1"/>
+          </a:fillRef>
+          <a:effectRef idx="2">
+            <a:schemeClr val="accent1"/>
+          </a:effectRef>
+          <a:fontRef idx="minor">
+            <a:schemeClr val="lt1"/>
+          </a:fontRef>
+        </p:style>
+        <p:txBody>
+          <a:bodyPr rtlCol="0" anchor="ctr"/>
+          <a:lstStyle/>
+          <a:p>
+            <a:pPr algn="ctr"/>
+            <a:endParaRPr/>
+          </a:p>
+        </p:txBody>
+      </p:sp>
+      <p:sp>
+        <p:nvSpPr>
+          <p:cNvPr id="8" name="TextBox 7"/>
+          <p:cNvSpPr txBox="1"/>
+          <p:nvPr/>
+        </p:nvSpPr>
+        <p:spPr>
+          <a:xfrm>
+            <a:off x="365760" y="6556248"/>
+            <a:ext cx="7315200" cy="274320"/>
+          </a:xfrm>
+          <a:prstGeom prst="rect">
+            <a:avLst/>
+          </a:prstGeom>
+          <a:noFill/>
+        </p:spPr>
+        <p:txBody>
+          <a:bodyPr wrap="square">
+            <a:spAutoFit/>
+          </a:bodyPr>
+          <a:lstStyle/>
+          <a:p>
+            <a:pPr algn="l"/>
+            <a:r>
+              <a:rPr sz="1100" b="0" i="0">
+                <a:solidFill>
+                  <a:srgbClr val="BFDBFF"/>
+                </a:solidFill>
+                <a:latin typeface="Calibri"/>
+              </a:rPr>
+              <a:t>Seminário de Andamento · 2026</a:t>
+            </a:r>
+          </a:p>
+        </p:txBody>
+      </p:sp>
+      <p:sp>
+        <p:nvSpPr>
+          <p:cNvPr id="9" name="TextBox 8"/>
+          <p:cNvSpPr txBox="1"/>
+          <p:nvPr/>
+        </p:nvSpPr>
+        <p:spPr>
+          <a:xfrm>
+            <a:off x="8686800" y="6556248"/>
+            <a:ext cx="3200400" cy="274320"/>
+          </a:xfrm>
+          <a:prstGeom prst="rect">
+            <a:avLst/>
+          </a:prstGeom>
+          <a:noFill/>
+        </p:spPr>
+        <p:txBody>
+          <a:bodyPr wrap="square">
+            <a:spAutoFit/>
+          </a:bodyPr>
+          <a:lstStyle/>
+          <a:p>
+            <a:pPr algn="r"/>
+            <a:r>
+              <a:rPr sz="1100" b="0" i="0">
+                <a:solidFill>
+                  <a:srgbClr val="BFDBFF"/>
+                </a:solidFill>
+                <a:latin typeface="Calibri"/>
+              </a:rPr>
+              <a:t>Eduardo Wanderley</a:t>
+            </a:r>
+          </a:p>
+        </p:txBody>
+      </p:sp>
+      <p:sp>
+        <p:nvSpPr>
+          <p:cNvPr id="10" name="TextBox 9"/>
+          <p:cNvSpPr txBox="1"/>
+          <p:nvPr/>
+        </p:nvSpPr>
+        <p:spPr>
+          <a:xfrm>
+            <a:off x="457200" y="1371600"/>
+            <a:ext cx="5486400" cy="347472"/>
+          </a:xfrm>
+          <a:prstGeom prst="rect">
+            <a:avLst/>
+          </a:prstGeom>
+          <a:noFill/>
+        </p:spPr>
+        <p:txBody>
+          <a:bodyPr wrap="square">
+            <a:spAutoFit/>
+          </a:bodyPr>
+          <a:lstStyle/>
+          <a:p>
+            <a:pPr algn="l"/>
+            <a:r>
+              <a:rPr sz="1600" b="1" i="0">
+                <a:solidFill>
+                  <a:srgbClr val="1B2A4A"/>
+                </a:solidFill>
+                <a:latin typeface="Calibri"/>
+              </a:rPr>
+              <a:t>RMSE vs. Ground Truth, por rota (N=10)</a:t>
+            </a:r>
+          </a:p>
+        </p:txBody>
+      </p:sp>
+      <p:pic>
+        <p:nvPicPr>
+          <p:cNvPr id="60" name="Picture 60" descr="RMSE medio vs ground truth, por rota e fonte de trajetoria"/>
+          <p:cNvPicPr>
+            <a:picLocks noChangeAspect="1"/>
+          </p:cNvPicPr>
+          <p:nvPr/>
+        </p:nvPicPr>
+        <p:blipFill>
+          <a:blip r:embed="rId2"/>
+          <a:stretch>
+            <a:fillRect/>
+          </a:stretch>
+        </p:blipFill>
+        <p:spPr>
+          <a:xfrm>
+            <a:off x="457200" y="1755648"/>
+            <a:ext cx="5000000" cy="3214286"/>
+          </a:xfrm>
+          <a:prstGeom prst="rect">
+            <a:avLst/>
+          </a:prstGeom>
+        </p:spPr>
+      </p:pic>
+      <p:sp>
+        <p:nvSpPr>
+          <p:cNvPr id="61" name="Rectangle 61"/>
+          <p:cNvSpPr/>
+          <p:nvPr/>
+        </p:nvSpPr>
+        <p:spPr>
+          <a:xfrm>
+            <a:off x="5757200" y="1755648"/>
+            <a:ext cx="5974552" cy="1450000"/>
+          </a:xfrm>
+          <a:prstGeom prst="rect">
+            <a:avLst/>
+          </a:prstGeom>
+          <a:solidFill>
+            <a:srgbClr val="F3F4F6"/>
+          </a:solidFill>
+          <a:ln>
+            <a:noFill/>
+          </a:ln>
+        </p:spPr>
+        <p:style>
+          <a:lnRef idx="1">
+            <a:schemeClr val="accent1"/>
+          </a:lnRef>
+          <a:fillRef idx="3">
+            <a:schemeClr val="accent1"/>
+          </a:fillRef>
+          <a:effectRef idx="2">
+            <a:schemeClr val="accent1"/>
+          </a:effectRef>
+          <a:fontRef idx="minor">
+            <a:schemeClr val="lt1"/>
+          </a:fontRef>
+        </p:style>
+        <p:txBody>
+          <a:bodyPr rtlCol="0" anchor="ctr"/>
+          <a:lstStyle/>
+          <a:p>
+            <a:pPr algn="ctr"/>
+            <a:endParaRPr/>
+          </a:p>
+        </p:txBody>
+      </p:sp>
+      <p:sp>
+        <p:nvSpPr>
+          <p:cNvPr id="62" name="Rectangle 62"/>
+          <p:cNvSpPr/>
+          <p:nvPr/>
+        </p:nvSpPr>
+        <p:spPr>
+          <a:xfrm>
+            <a:off x="5757200" y="1755648"/>
+            <a:ext cx="5974552" cy="54864"/>
+          </a:xfrm>
+          <a:prstGeom prst="rect">
+            <a:avLst/>
+          </a:prstGeom>
+          <a:solidFill>
+            <a:srgbClr val="1B2A4A"/>
+          </a:solidFill>
+          <a:ln>
+            <a:noFill/>
+          </a:ln>
+        </p:spPr>
+        <p:style>
+          <a:lnRef idx="1">
+            <a:schemeClr val="accent1"/>
+          </a:lnRef>
+          <a:fillRef idx="3">
+            <a:schemeClr val="accent1"/>
+          </a:fillRef>
+          <a:effectRef idx="2">
+            <a:schemeClr val="accent1"/>
+          </a:effectRef>
+          <a:fontRef idx="minor">
+            <a:schemeClr val="lt1"/>
+          </a:fontRef>
+        </p:style>
+        <p:txBody>
+          <a:bodyPr rtlCol="0" anchor="ctr"/>
+          <a:lstStyle/>
+          <a:p>
+            <a:pPr algn="ctr"/>
+            <a:endParaRPr/>
+          </a:p>
+        </p:txBody>
+      </p:sp>
+      <p:sp>
+        <p:nvSpPr>
+          <p:cNvPr id="63" name="TextBox 63"/>
+          <p:cNvSpPr txBox="1"/>
+          <p:nvPr/>
+        </p:nvSpPr>
+        <p:spPr>
+          <a:xfrm>
+            <a:off x="5894360" y="1847088"/>
+            <a:ext cx="5700232" cy="292608"/>
+          </a:xfrm>
+          <a:prstGeom prst="rect">
+            <a:avLst/>
+          </a:prstGeom>
+          <a:noFill/>
+        </p:spPr>
+        <p:txBody>
+          <a:bodyPr wrap="square">
+            <a:spAutoFit/>
+          </a:bodyPr>
+          <a:lstStyle/>
+          <a:p>
+            <a:pPr algn="l"/>
+            <a:r>
+              <a:rPr sz="1200" b="0" i="0">
+                <a:solidFill>
+                  <a:srgbClr val="6B7280"/>
+                </a:solidFill>
+                <a:latin typeface="Calibri"/>
+              </a:rPr>
+              <a:t>Maior diferença — Rota Loop (~11,3 m, 4 curvas)</a:t>
+            </a:r>
+          </a:p>
+        </p:txBody>
+      </p:sp>
+      <p:sp>
+        <p:nvSpPr>
+          <p:cNvPr id="64" name="TextBox 64"/>
+          <p:cNvSpPr txBox="1"/>
+          <p:nvPr/>
+        </p:nvSpPr>
+        <p:spPr>
+          <a:xfrm>
+            <a:off x="5894360" y="2175648"/>
+            <a:ext cx="5700232" cy="500000"/>
+          </a:xfrm>
+          <a:prstGeom prst="rect">
+            <a:avLst/>
+          </a:prstGeom>
+          <a:noFill/>
+        </p:spPr>
+        <p:txBody>
+          <a:bodyPr wrap="square">
+            <a:spAutoFit/>
+          </a:bodyPr>
+          <a:lstStyle/>
+          <a:p>
+            <a:pPr algn="l"/>
+            <a:r>
+              <a:rPr sz="2400" b="1" i="0">
+                <a:solidFill>
+                  <a:srgbClr val="1B2A4A"/>
+                </a:solidFill>
+                <a:latin typeface="Calibri"/>
+              </a:rPr>
+              <a:t>~12 cm</a:t>
+            </a:r>
+          </a:p>
+        </p:txBody>
+      </p:sp>
+      <p:sp>
+        <p:nvSpPr>
+          <p:cNvPr id="65" name="TextBox 65"/>
+          <p:cNvSpPr txBox="1"/>
+          <p:nvPr/>
+        </p:nvSpPr>
+        <p:spPr>
+          <a:xfrm>
+            <a:off x="5894360" y="2705648"/>
+            <a:ext cx="5700232" cy="450000"/>
+          </a:xfrm>
+          <a:prstGeom prst="rect">
+            <a:avLst/>
+          </a:prstGeom>
+          <a:noFill/>
+        </p:spPr>
+        <p:txBody>
+          <a:bodyPr wrap="square">
+            <a:spAutoFit/>
+          </a:bodyPr>
+          <a:lstStyle/>
+          <a:p>
+            <a:pPr algn="l"/>
+            <a:r>
+              <a:rPr sz="1100" b="0" i="0">
+                <a:solidFill>
+                  <a:srgbClr val="6B7280"/>
+                </a:solidFill>
+                <a:latin typeface="Calibri"/>
+              </a:rPr>
+              <a:t>odom 14,27 cm  vs.  pose 2,45 cm</a:t>
+            </a:r>
+          </a:p>
+        </p:txBody>
+      </p:sp>
+      <p:sp>
+        <p:nvSpPr>
+          <p:cNvPr id="66" name="Rectangle 66"/>
+          <p:cNvSpPr/>
+          <p:nvPr/>
+        </p:nvSpPr>
+        <p:spPr>
+          <a:xfrm>
+            <a:off x="5757200" y="3355648"/>
+            <a:ext cx="5974552" cy="1450000"/>
+          </a:xfrm>
+          <a:prstGeom prst="rect">
+            <a:avLst/>
+          </a:prstGeom>
+          <a:solidFill>
+            <a:srgbClr val="F3F4F6"/>
+          </a:solidFill>
+          <a:ln>
+            <a:noFill/>
+          </a:ln>
+        </p:spPr>
+        <p:style>
+          <a:lnRef idx="1">
+            <a:schemeClr val="accent1"/>
+          </a:lnRef>
+          <a:fillRef idx="3">
+            <a:schemeClr val="accent1"/>
+          </a:fillRef>
+          <a:effectRef idx="2">
+            <a:schemeClr val="accent1"/>
+          </a:effectRef>
+          <a:fontRef idx="minor">
+            <a:schemeClr val="lt1"/>
+          </a:fontRef>
+        </p:style>
+        <p:txBody>
+          <a:bodyPr rtlCol="0" anchor="ctr"/>
+          <a:lstStyle/>
+          <a:p>
+            <a:pPr algn="ctr"/>
+            <a:endParaRPr/>
+          </a:p>
+        </p:txBody>
+      </p:sp>
+      <p:sp>
+        <p:nvSpPr>
+          <p:cNvPr id="67" name="Rectangle 67"/>
+          <p:cNvSpPr/>
+          <p:nvPr/>
+        </p:nvSpPr>
+        <p:spPr>
+          <a:xfrm>
+            <a:off x="5757200" y="3355648"/>
+            <a:ext cx="5974552" cy="54864"/>
+          </a:xfrm>
+          <a:prstGeom prst="rect">
+            <a:avLst/>
+          </a:prstGeom>
+          <a:solidFill>
+            <a:srgbClr val="1B2A4A"/>
+          </a:solidFill>
+          <a:ln>
+            <a:noFill/>
+          </a:ln>
+        </p:spPr>
+        <p:style>
+          <a:lnRef idx="1">
+            <a:schemeClr val="accent1"/>
+          </a:lnRef>
+          <a:fillRef idx="3">
+            <a:schemeClr val="accent1"/>
+          </a:fillRef>
+          <a:effectRef idx="2">
+            <a:schemeClr val="accent1"/>
+          </a:effectRef>
+          <a:fontRef idx="minor">
+            <a:schemeClr val="lt1"/>
+          </a:fontRef>
+        </p:style>
+        <p:txBody>
+          <a:bodyPr rtlCol="0" anchor="ctr"/>
+          <a:lstStyle/>
+          <a:p>
+            <a:pPr algn="ctr"/>
+            <a:endParaRPr/>
+          </a:p>
+        </p:txBody>
+      </p:sp>
+      <p:sp>
+        <p:nvSpPr>
+          <p:cNvPr id="68" name="TextBox 68"/>
+          <p:cNvSpPr txBox="1"/>
+          <p:nvPr/>
+        </p:nvSpPr>
+        <p:spPr>
+          <a:xfrm>
+            <a:off x="5894360" y="3447088"/>
+            <a:ext cx="5700232" cy="292608"/>
+          </a:xfrm>
+          <a:prstGeom prst="rect">
+            <a:avLst/>
+          </a:prstGeom>
+          <a:noFill/>
+        </p:spPr>
+        <p:txBody>
+          <a:bodyPr wrap="square">
+            <a:spAutoFit/>
+          </a:bodyPr>
+          <a:lstStyle/>
+          <a:p>
+            <a:pPr algn="l"/>
+            <a:r>
+              <a:rPr sz="1200" b="0" i="0">
+                <a:solidFill>
+                  <a:srgbClr val="6B7280"/>
+                </a:solidFill>
+                <a:latin typeface="Calibri"/>
+              </a:rPr>
+              <a:t>Rota Curta (~0,9 m) — mesma da campanha principal</a:t>
+            </a:r>
+          </a:p>
+        </p:txBody>
+      </p:sp>
+      <p:sp>
+        <p:nvSpPr>
+          <p:cNvPr id="69" name="TextBox 69"/>
+          <p:cNvSpPr txBox="1"/>
+          <p:nvPr/>
+        </p:nvSpPr>
+        <p:spPr>
+          <a:xfrm>
+            <a:off x="5894360" y="3775648"/>
+            <a:ext cx="5700232" cy="500000"/>
+          </a:xfrm>
+          <a:prstGeom prst="rect">
+            <a:avLst/>
+          </a:prstGeom>
+          <a:noFill/>
+        </p:spPr>
+        <p:txBody>
+          <a:bodyPr wrap="square">
+            <a:spAutoFit/>
+          </a:bodyPr>
+          <a:lstStyle/>
+          <a:p>
+            <a:pPr algn="l"/>
+            <a:r>
+              <a:rPr sz="2400" b="1" i="0">
+                <a:solidFill>
+                  <a:srgbClr val="1B2A4A"/>
+                </a:solidFill>
+                <a:latin typeface="Calibri"/>
+              </a:rPr>
+              <a:t>&lt; 4 cm</a:t>
+            </a:r>
+          </a:p>
+        </p:txBody>
+      </p:sp>
+      <p:sp>
+        <p:nvSpPr>
+          <p:cNvPr id="70" name="TextBox 70"/>
+          <p:cNvSpPr txBox="1"/>
+          <p:nvPr/>
+        </p:nvSpPr>
+        <p:spPr>
+          <a:xfrm>
+            <a:off x="5894360" y="4305648"/>
+            <a:ext cx="5700232" cy="450000"/>
+          </a:xfrm>
+          <a:prstGeom prst="rect">
+            <a:avLst/>
+          </a:prstGeom>
+          <a:noFill/>
+        </p:spPr>
+        <p:txBody>
+          <a:bodyPr wrap="square">
+            <a:spAutoFit/>
+          </a:bodyPr>
+          <a:lstStyle/>
+          <a:p>
+            <a:pPr algn="l"/>
+            <a:r>
+              <a:rPr sz="1100" b="0" i="0">
+                <a:solidFill>
+                  <a:srgbClr val="6B7280"/>
+                </a:solidFill>
+                <a:latin typeface="Calibri"/>
+              </a:rPr>
+              <a:t>odom 0,01 cm  vs.  pose 3,28 cm — diferença desprezível</a:t>
+            </a:r>
+          </a:p>
+        </p:txBody>
+      </p:sp>
+      <p:sp>
+        <p:nvSpPr>
+          <p:cNvPr id="52" name="Rectangle 51"/>
+          <p:cNvSpPr/>
+          <p:nvPr/>
+        </p:nvSpPr>
+        <p:spPr>
+          <a:xfrm>
+            <a:off x="457200" y="5100000"/>
+            <a:ext cx="11274552" cy="950000"/>
+          </a:xfrm>
+          <a:prstGeom prst="rect">
+            <a:avLst/>
+          </a:prstGeom>
+          <a:solidFill>
+            <a:srgbClr val="F3F4F6"/>
+          </a:solidFill>
+          <a:ln>
+            <a:noFill/>
+          </a:ln>
+        </p:spPr>
+        <p:style>
+          <a:lnRef idx="1">
+            <a:schemeClr val="accent1"/>
+          </a:lnRef>
+          <a:fillRef idx="3">
+            <a:schemeClr val="accent1"/>
+          </a:fillRef>
+          <a:effectRef idx="2">
+            <a:schemeClr val="accent1"/>
+          </a:effectRef>
+          <a:fontRef idx="minor">
+            <a:schemeClr val="lt1"/>
+          </a:fontRef>
+        </p:style>
+        <p:txBody>
+          <a:bodyPr rtlCol="0" anchor="ctr"/>
+          <a:lstStyle/>
+          <a:p>
+            <a:pPr algn="ctr"/>
+            <a:endParaRPr/>
+          </a:p>
+        </p:txBody>
+      </p:sp>
+      <p:sp>
+        <p:nvSpPr>
+          <p:cNvPr id="53" name="Rectangle 52"/>
+          <p:cNvSpPr/>
+          <p:nvPr/>
+        </p:nvSpPr>
+        <p:spPr>
+          <a:xfrm>
+            <a:off x="457200" y="5100000"/>
+            <a:ext cx="91440" cy="950000"/>
+          </a:xfrm>
+          <a:prstGeom prst="rect">
+            <a:avLst/>
+          </a:prstGeom>
+          <a:solidFill>
+            <a:srgbClr val="059669"/>
+          </a:solidFill>
+          <a:ln>
+            <a:noFill/>
+          </a:ln>
+        </p:spPr>
+        <p:style>
+          <a:lnRef idx="1">
+            <a:schemeClr val="accent1"/>
+          </a:lnRef>
+          <a:fillRef idx="3">
+            <a:schemeClr val="accent1"/>
+          </a:fillRef>
+          <a:effectRef idx="2">
+            <a:schemeClr val="accent1"/>
+          </a:effectRef>
+          <a:fontRef idx="minor">
+            <a:schemeClr val="lt1"/>
+          </a:fontRef>
+        </p:style>
+        <p:txBody>
+          <a:bodyPr rtlCol="0" anchor="ctr"/>
+          <a:lstStyle/>
+          <a:p>
+            <a:pPr algn="ctr"/>
+            <a:endParaRPr/>
+          </a:p>
+        </p:txBody>
+      </p:sp>
+      <p:sp>
+        <p:nvSpPr>
+          <p:cNvPr id="54" name="TextBox 53"/>
+          <p:cNvSpPr txBox="1"/>
+          <p:nvPr/>
+        </p:nvSpPr>
+        <p:spPr>
+          <a:xfrm>
+            <a:off x="685800" y="5173152"/>
+            <a:ext cx="10972800" cy="347472"/>
+          </a:xfrm>
+          <a:prstGeom prst="rect">
+            <a:avLst/>
+          </a:prstGeom>
+          <a:noFill/>
+        </p:spPr>
+        <p:txBody>
+          <a:bodyPr wrap="square">
+            <a:spAutoFit/>
+          </a:bodyPr>
+          <a:lstStyle/>
+          <a:p>
+            <a:pPr algn="l"/>
+            <a:r>
+              <a:rPr sz="1500" b="1" i="0">
+                <a:solidFill>
+                  <a:srgbClr val="1B2A4A"/>
+                </a:solidFill>
+                <a:latin typeface="Calibri"/>
+              </a:rPr>
+              <a:t>Rota curta: diferença desprezível (&lt; 4 cm) — valida a escolha metodológica da campanha principal.</a:t>
+            </a:r>
+          </a:p>
+        </p:txBody>
+      </p:sp>
+      <p:sp>
+        <p:nvSpPr>
+          <p:cNvPr id="55" name="TextBox 54"/>
+          <p:cNvSpPr txBox="1"/>
+          <p:nvPr/>
+        </p:nvSpPr>
+        <p:spPr>
+          <a:xfrm>
+            <a:off x="685800" y="5540624"/>
+            <a:ext cx="10972800" cy="411480"/>
+          </a:xfrm>
+          <a:prstGeom prst="rect">
+            <a:avLst/>
+          </a:prstGeom>
+          <a:noFill/>
+        </p:spPr>
+        <p:txBody>
+          <a:bodyPr wrap="square">
+            <a:spAutoFit/>
+          </a:bodyPr>
+          <a:lstStyle/>
+          <a:p>
+            <a:pPr algn="l"/>
+            <a:r>
+              <a:rPr sz="1300" b="0" i="0">
+                <a:solidFill>
+                  <a:srgbClr val="6B7280"/>
+                </a:solidFill>
+                <a:latin typeface="Calibri"/>
+              </a:rPr>
+              <a:t>Em rotas mais longas, a diferença chega a ~12 cm — a fonte de trajetória passa a importar para a conclusão sobre repetibilidade.</a:t>
             </a:r>
           </a:p>
         </p:txBody>

</xml_diff>

<commit_message>
Corrige contradição real com a dissertação sobre multi-robô e adiciona o painel Missão Coordenada
A fala e o pptx afirmavam "2 robôs simultâneos, validado/estável", mas o
Capítulo 9 (Limitações) é explícito: essa conclusão preliminar foi
invalidada por um bug real (salto no relógio simulado sob Nav2 duplo
simultâneo), e a arquitetura final usa ativação sequencial de um robô por
vez, com 70% de taxa de sucesso — "qualitativo/exploratório", não uma
validação. Corrigido nos Slides 5 e 14 (fala) e nas mesmas duas telas do
pptx, pra não contradizer o texto escrito.

Também adiciona ao Slide 5 (fala + pptx) uma menção ao painel "Missão
Coordenada" (dissertacao/chapters/04_arquitetura.tex, Seção 4.x), um
recurso real e implementado que elimina terminais pra subir a simulação,
mas que não aparecia em nenhum lugar da apresentação.

Co-Authored-By: Claude Sonnet 5 <noreply@anthropic.com>
</commit_message>
<xml_diff>
--- a/disserta-apresenta/apresentacao_seminario.pptx
+++ b/disserta-apresenta/apresentacao_seminario.pptx
@@ -7009,7 +7009,7 @@
                 </a:solidFill>
                 <a:latin typeface="Calibri"/>
               </a:rPr>
-              <a:t>✓  Multi-robô operacional (2 robôs simultâneos, validado) + camada de agentes de IA</a:t>
+              <a:t>✓  Multi-robô via ativação sequencial (2 robôs, 70% sucesso) + camada de agentes de IA</a:t>
             </a:r>
           </a:p>
         </p:txBody>
@@ -11592,7 +11592,7 @@
                 </a:solidFill>
                 <a:latin typeface="Calibri"/>
               </a:rPr>
-              <a:t>React + Vite  ·  FastAPI  ·  Editor JSON  ·  Painel multi-robô  ·  Painel de Agentes de IA</a:t>
+              <a:t>React + Vite  ·  FastAPI  ·  Editor JSON  ·  Missão Coordenada  ·  Painel de Agentes de IA</a:t>
             </a:r>
           </a:p>
         </p:txBody>
@@ -11706,7 +11706,7 @@
                 </a:solidFill>
                 <a:latin typeface="Calibri"/>
               </a:rPr>
-              <a:t>7 serviços ROS 2  ·  Record / Replay  ·  Nav2 Actions  ·  Até 3 robôs simultâneos</a:t>
+              <a:t>7 serviços ROS 2  ·  Record / Replay  ·  Nav2 Actions  ·  Multi-robô via ativação sequencial</a:t>
             </a:r>
           </a:p>
         </p:txBody>

</xml_diff>